<commit_message>
Add RPi GH Runner Setup
</commit_message>
<xml_diff>
--- a/profile/ImageSource/images.pptx
+++ b/profile/ImageSource/images.pptx
@@ -5,15 +5,16 @@
     <p:sldMasterId id="2147485431" r:id="rId6"/>
   </p:sldMasterIdLst>
   <p:notesMasterIdLst>
-    <p:notesMasterId r:id="rId10"/>
+    <p:notesMasterId r:id="rId11"/>
   </p:notesMasterIdLst>
   <p:handoutMasterIdLst>
-    <p:handoutMasterId r:id="rId11"/>
+    <p:handoutMasterId r:id="rId12"/>
   </p:handoutMasterIdLst>
   <p:sldIdLst>
     <p:sldId id="2086971674" r:id="rId7"/>
     <p:sldId id="2147483646" r:id="rId8"/>
     <p:sldId id="258" r:id="rId9"/>
+    <p:sldId id="2147483647" r:id="rId10"/>
   </p:sldIdLst>
   <p:sldSz cx="12192000" cy="6858000"/>
   <p:notesSz cx="6858000" cy="9144000"/>
@@ -498,7 +499,7 @@
               <a:pPr>
                 <a:defRPr/>
               </a:pPr>
-              <a:t>2/16/2026</a:t>
+              <a:t>5/29/2026</a:t>
             </a:fld>
             <a:endParaRPr lang="en-US" altLang="en-US"/>
           </a:p>
@@ -11063,10 +11064,10 @@
               </a:buClr>
               <a:buFontTx/>
               <a:buBlip>
-                <a:blip r:embed="rId4">
+                <a:blip>
                   <a:extLst>
                     <a:ext uri="{96DAC541-7B7A-43D3-8B79-37D633B846F1}">
-                      <asvg:svgBlip xmlns:asvg="http://schemas.microsoft.com/office/drawing/2016/SVG/main" r:embed="rId5"/>
+                      <asvg:svgBlip xmlns:asvg="http://schemas.microsoft.com/office/drawing/2016/SVG/main" r:embed="rId4"/>
                     </a:ext>
                   </a:extLst>
                 </a:blip>
@@ -11121,10 +11122,10 @@
               <a:buSzPct val="80000"/>
               <a:buFontTx/>
               <a:buBlip>
-                <a:blip r:embed="rId6">
+                <a:blip>
                   <a:extLst>
                     <a:ext uri="{96DAC541-7B7A-43D3-8B79-37D633B846F1}">
-                      <asvg:svgBlip xmlns:asvg="http://schemas.microsoft.com/office/drawing/2016/SVG/main" r:embed="rId7"/>
+                      <asvg:svgBlip xmlns:asvg="http://schemas.microsoft.com/office/drawing/2016/SVG/main" r:embed="rId5"/>
                     </a:ext>
                   </a:extLst>
                 </a:blip>
@@ -11179,10 +11180,10 @@
               <a:buSzPct val="80000"/>
               <a:buFontTx/>
               <a:buBlip>
-                <a:blip r:embed="rId6">
+                <a:blip>
                   <a:extLst>
                     <a:ext uri="{96DAC541-7B7A-43D3-8B79-37D633B846F1}">
-                      <asvg:svgBlip xmlns:asvg="http://schemas.microsoft.com/office/drawing/2016/SVG/main" r:embed="rId7"/>
+                      <asvg:svgBlip xmlns:asvg="http://schemas.microsoft.com/office/drawing/2016/SVG/main" r:embed="rId5"/>
                     </a:ext>
                   </a:extLst>
                 </a:blip>
@@ -12026,10 +12027,10 @@
           <p:nvPr/>
         </p:nvPicPr>
         <p:blipFill>
-          <a:blip r:embed="rId8">
+          <a:blip>
             <a:extLst>
               <a:ext uri="{96DAC541-7B7A-43D3-8B79-37D633B846F1}">
-                <asvg:svgBlip xmlns:asvg="http://schemas.microsoft.com/office/drawing/2016/SVG/main" r:embed="rId9"/>
+                <asvg:svgBlip xmlns:asvg="http://schemas.microsoft.com/office/drawing/2016/SVG/main" r:embed="rId6"/>
               </a:ext>
             </a:extLst>
           </a:blip>
@@ -12082,10 +12083,10 @@
             <p:nvPr/>
           </p:nvPicPr>
           <p:blipFill>
-            <a:blip r:embed="rId10">
+            <a:blip>
               <a:extLst>
                 <a:ext uri="{96DAC541-7B7A-43D3-8B79-37D633B846F1}">
-                  <asvg:svgBlip xmlns:asvg="http://schemas.microsoft.com/office/drawing/2016/SVG/main" r:embed="rId11"/>
+                  <asvg:svgBlip xmlns:asvg="http://schemas.microsoft.com/office/drawing/2016/SVG/main" r:embed="rId7"/>
                 </a:ext>
               </a:extLst>
             </a:blip>
@@ -12587,7 +12588,7 @@
           <p:nvPr/>
         </p:nvPicPr>
         <p:blipFill>
-          <a:blip r:embed="rId12"/>
+          <a:blip r:embed="rId8"/>
           <a:stretch>
             <a:fillRect/>
           </a:stretch>
@@ -12617,7 +12618,7 @@
           <p:nvPr/>
         </p:nvPicPr>
         <p:blipFill>
-          <a:blip r:embed="rId13"/>
+          <a:blip r:embed="rId9"/>
           <a:stretch>
             <a:fillRect/>
           </a:stretch>
@@ -17134,6 +17135,466 @@
 </p:sld>
 </file>
 
+<file path=ppt/slides/slide4.xml><?xml version="1.0" encoding="utf-8"?>
+<p:sld xmlns:a="http://schemas.openxmlformats.org/drawingml/2006/main" xmlns:r="http://schemas.openxmlformats.org/officeDocument/2006/relationships" xmlns:p="http://schemas.openxmlformats.org/presentationml/2006/main">
+  <p:cSld>
+    <p:spTree>
+      <p:nvGrpSpPr>
+        <p:cNvPr id="1" name=""/>
+        <p:cNvGrpSpPr/>
+        <p:nvPr/>
+      </p:nvGrpSpPr>
+      <p:grpSpPr>
+        <a:xfrm>
+          <a:off x="0" y="0"/>
+          <a:ext cx="0" cy="0"/>
+          <a:chOff x="0" y="0"/>
+          <a:chExt cx="0" cy="0"/>
+        </a:xfrm>
+      </p:grpSpPr>
+      <p:sp>
+        <p:nvSpPr>
+          <p:cNvPr id="2" name="Title 1">
+            <a:extLst>
+              <a:ext uri="{FF2B5EF4-FFF2-40B4-BE49-F238E27FC236}">
+                <a16:creationId xmlns:a16="http://schemas.microsoft.com/office/drawing/2014/main" id="{D7A6A9D5-CE8E-075A-6556-361460157CE2}"/>
+              </a:ext>
+            </a:extLst>
+          </p:cNvPr>
+          <p:cNvSpPr>
+            <a:spLocks noGrp="1"/>
+          </p:cNvSpPr>
+          <p:nvPr>
+            <p:ph type="title"/>
+          </p:nvPr>
+        </p:nvSpPr>
+        <p:spPr/>
+        <p:txBody>
+          <a:bodyPr/>
+          <a:lstStyle/>
+          <a:p>
+            <a:endParaRPr lang="en-US"/>
+          </a:p>
+        </p:txBody>
+      </p:sp>
+      <p:sp>
+        <p:nvSpPr>
+          <p:cNvPr id="3" name="Text Placeholder 2">
+            <a:extLst>
+              <a:ext uri="{FF2B5EF4-FFF2-40B4-BE49-F238E27FC236}">
+                <a16:creationId xmlns:a16="http://schemas.microsoft.com/office/drawing/2014/main" id="{810F1926-8522-B05D-B4D2-620F64BC3AB2}"/>
+              </a:ext>
+            </a:extLst>
+          </p:cNvPr>
+          <p:cNvSpPr>
+            <a:spLocks noGrp="1"/>
+          </p:cNvSpPr>
+          <p:nvPr>
+            <p:ph type="body" sz="quarter" idx="13"/>
+          </p:nvPr>
+        </p:nvSpPr>
+        <p:spPr/>
+        <p:txBody>
+          <a:bodyPr/>
+          <a:lstStyle/>
+          <a:p>
+            <a:endParaRPr lang="en-US"/>
+          </a:p>
+        </p:txBody>
+      </p:sp>
+      <p:sp>
+        <p:nvSpPr>
+          <p:cNvPr id="8" name="TextBox 7">
+            <a:extLst>
+              <a:ext uri="{FF2B5EF4-FFF2-40B4-BE49-F238E27FC236}">
+                <a16:creationId xmlns:a16="http://schemas.microsoft.com/office/drawing/2014/main" id="{F4EBAEAD-944A-517E-FFFC-E337F8392617}"/>
+              </a:ext>
+            </a:extLst>
+          </p:cNvPr>
+          <p:cNvSpPr txBox="1"/>
+          <p:nvPr/>
+        </p:nvSpPr>
+        <p:spPr>
+          <a:xfrm>
+            <a:off x="4889770" y="1884445"/>
+            <a:ext cx="2373550" cy="2046714"/>
+          </a:xfrm>
+          <a:prstGeom prst="rect">
+            <a:avLst/>
+          </a:prstGeom>
+          <a:noFill/>
+        </p:spPr>
+        <p:txBody>
+          <a:bodyPr wrap="square" lIns="0" tIns="0" rIns="0" bIns="0" rtlCol="0">
+            <a:spAutoFit/>
+          </a:bodyPr>
+          <a:lstStyle/>
+          <a:p>
+            <a:pPr marL="0" indent="0" algn="l" defTabSz="914400" rtl="0" eaLnBrk="1" latinLnBrk="0" hangingPunct="1">
+              <a:lnSpc>
+                <a:spcPct val="90000"/>
+              </a:lnSpc>
+              <a:spcBef>
+                <a:spcPts val="0"/>
+              </a:spcBef>
+              <a:spcAft>
+                <a:spcPts val="600"/>
+              </a:spcAft>
+              <a:buFont typeface="Arial" panose="020B0604020202020204" pitchFamily="34" charset="0"/>
+              <a:buNone/>
+            </a:pPr>
+            <a:r>
+              <a:rPr lang="en-US" sz="1100" b="1" dirty="0">
+                <a:solidFill>
+                  <a:schemeClr val="tx2"/>
+                </a:solidFill>
+                <a:latin typeface="+mn-lt"/>
+                <a:ea typeface="+mn-ea"/>
+              </a:rPr>
+              <a:t>Installed tools and software:</a:t>
+            </a:r>
+          </a:p>
+          <a:p>
+            <a:pPr marL="168275" indent="-168275" algn="l" defTabSz="914400" rtl="0" eaLnBrk="1" latinLnBrk="0" hangingPunct="1">
+              <a:lnSpc>
+                <a:spcPct val="90000"/>
+              </a:lnSpc>
+              <a:spcBef>
+                <a:spcPts val="0"/>
+              </a:spcBef>
+              <a:spcAft>
+                <a:spcPts val="600"/>
+              </a:spcAft>
+              <a:buFont typeface="Arial" panose="020B0604020202020204" pitchFamily="34" charset="0"/>
+              <a:buChar char="•"/>
+              <a:tabLst>
+                <a:tab pos="344488" algn="l"/>
+              </a:tabLst>
+            </a:pPr>
+            <a:r>
+              <a:rPr lang="en-US" sz="1100" dirty="0" err="1">
+                <a:solidFill>
+                  <a:schemeClr val="tx2"/>
+                </a:solidFill>
+                <a:latin typeface="+mn-lt"/>
+                <a:ea typeface="+mn-ea"/>
+              </a:rPr>
+              <a:t>pyOCD</a:t>
+            </a:r>
+            <a:r>
+              <a:rPr lang="en-US" sz="1100" dirty="0">
+                <a:solidFill>
+                  <a:schemeClr val="tx2"/>
+                </a:solidFill>
+                <a:latin typeface="+mn-lt"/>
+                <a:ea typeface="+mn-ea"/>
+              </a:rPr>
+              <a:t> for flash download</a:t>
+            </a:r>
+            <a:br>
+              <a:rPr lang="en-US" sz="1100" dirty="0">
+                <a:solidFill>
+                  <a:schemeClr val="tx2"/>
+                </a:solidFill>
+                <a:latin typeface="+mn-lt"/>
+                <a:ea typeface="+mn-ea"/>
+              </a:rPr>
+            </a:br>
+            <a:r>
+              <a:rPr lang="en-US" sz="1100" dirty="0">
+                <a:solidFill>
+                  <a:schemeClr val="tx2"/>
+                </a:solidFill>
+                <a:latin typeface="+mn-lt"/>
+                <a:ea typeface="+mn-ea"/>
+              </a:rPr>
+              <a:t>and test execution</a:t>
+            </a:r>
+          </a:p>
+          <a:p>
+            <a:pPr marL="168275" indent="-168275" algn="l" defTabSz="914400" rtl="0" eaLnBrk="1" latinLnBrk="0" hangingPunct="1">
+              <a:lnSpc>
+                <a:spcPct val="90000"/>
+              </a:lnSpc>
+              <a:spcBef>
+                <a:spcPts val="0"/>
+              </a:spcBef>
+              <a:spcAft>
+                <a:spcPts val="600"/>
+              </a:spcAft>
+              <a:buFont typeface="Arial" panose="020B0604020202020204" pitchFamily="34" charset="0"/>
+              <a:buChar char="•"/>
+              <a:tabLst>
+                <a:tab pos="344488" algn="l"/>
+              </a:tabLst>
+            </a:pPr>
+            <a:r>
+              <a:rPr lang="en-US" sz="1100" dirty="0">
+                <a:solidFill>
+                  <a:schemeClr val="tx2"/>
+                </a:solidFill>
+                <a:latin typeface="+mn-lt"/>
+                <a:ea typeface="+mn-ea"/>
+              </a:rPr>
+              <a:t>CMSIS-Toolbox for software</a:t>
+            </a:r>
+            <a:br>
+              <a:rPr lang="en-US" sz="1100" dirty="0">
+                <a:solidFill>
+                  <a:schemeClr val="tx2"/>
+                </a:solidFill>
+                <a:latin typeface="+mn-lt"/>
+                <a:ea typeface="+mn-ea"/>
+              </a:rPr>
+            </a:br>
+            <a:r>
+              <a:rPr lang="en-US" sz="1100" dirty="0">
+                <a:solidFill>
+                  <a:schemeClr val="tx2"/>
+                </a:solidFill>
+                <a:latin typeface="+mn-lt"/>
+                <a:ea typeface="+mn-ea"/>
+              </a:rPr>
+              <a:t>pack installation</a:t>
+            </a:r>
+          </a:p>
+          <a:p>
+            <a:pPr marL="168275" indent="-168275" algn="l" defTabSz="914400" rtl="0" eaLnBrk="1" latinLnBrk="0" hangingPunct="1">
+              <a:lnSpc>
+                <a:spcPct val="90000"/>
+              </a:lnSpc>
+              <a:spcBef>
+                <a:spcPts val="0"/>
+              </a:spcBef>
+              <a:spcAft>
+                <a:spcPts val="600"/>
+              </a:spcAft>
+              <a:buFont typeface="Arial" panose="020B0604020202020204" pitchFamily="34" charset="0"/>
+              <a:buChar char="•"/>
+              <a:tabLst>
+                <a:tab pos="344488" algn="l"/>
+              </a:tabLst>
+            </a:pPr>
+            <a:r>
+              <a:rPr lang="en-US" sz="1100" dirty="0">
+                <a:solidFill>
+                  <a:schemeClr val="tx2"/>
+                </a:solidFill>
+                <a:latin typeface="+mn-lt"/>
+                <a:ea typeface="+mn-ea"/>
+              </a:rPr>
+              <a:t>DFP and BSP software packs for flash programming and debug connection </a:t>
+            </a:r>
+          </a:p>
+          <a:p>
+            <a:pPr marL="168275" indent="-168275" algn="l" defTabSz="914400" rtl="0" eaLnBrk="1" latinLnBrk="0" hangingPunct="1">
+              <a:lnSpc>
+                <a:spcPct val="90000"/>
+              </a:lnSpc>
+              <a:spcBef>
+                <a:spcPts val="0"/>
+              </a:spcBef>
+              <a:spcAft>
+                <a:spcPts val="600"/>
+              </a:spcAft>
+              <a:buFont typeface="Arial" panose="020B0604020202020204" pitchFamily="34" charset="0"/>
+              <a:buChar char="•"/>
+              <a:tabLst>
+                <a:tab pos="344488" algn="l"/>
+              </a:tabLst>
+            </a:pPr>
+            <a:r>
+              <a:rPr lang="en-US" sz="1100" dirty="0">
+                <a:solidFill>
+                  <a:schemeClr val="tx2"/>
+                </a:solidFill>
+                <a:latin typeface="+mn-lt"/>
+                <a:ea typeface="+mn-ea"/>
+              </a:rPr>
+              <a:t>SDSIO-Server (optional) for running test using SDS-Framework</a:t>
+            </a:r>
+          </a:p>
+          <a:p>
+            <a:pPr marL="168275" indent="-168275" algn="l" defTabSz="914400" rtl="0" eaLnBrk="1" latinLnBrk="0" hangingPunct="1">
+              <a:lnSpc>
+                <a:spcPct val="90000"/>
+              </a:lnSpc>
+              <a:spcBef>
+                <a:spcPts val="0"/>
+              </a:spcBef>
+              <a:spcAft>
+                <a:spcPts val="600"/>
+              </a:spcAft>
+              <a:buFont typeface="Arial" panose="020B0604020202020204" pitchFamily="34" charset="0"/>
+              <a:buChar char="•"/>
+              <a:tabLst>
+                <a:tab pos="344488" algn="l"/>
+              </a:tabLst>
+            </a:pPr>
+            <a:endParaRPr lang="en-US" sz="2100" kern="1200" dirty="0">
+              <a:solidFill>
+                <a:schemeClr val="tx2"/>
+              </a:solidFill>
+              <a:latin typeface="+mn-lt"/>
+              <a:ea typeface="+mn-ea"/>
+              <a:cs typeface="+mn-cs"/>
+            </a:endParaRPr>
+          </a:p>
+        </p:txBody>
+      </p:sp>
+      <p:pic>
+        <p:nvPicPr>
+          <p:cNvPr id="10" name="Picture 9">
+            <a:extLst>
+              <a:ext uri="{FF2B5EF4-FFF2-40B4-BE49-F238E27FC236}">
+                <a16:creationId xmlns:a16="http://schemas.microsoft.com/office/drawing/2014/main" id="{6BC58DEC-E49B-BEA9-9365-D803F879A067}"/>
+              </a:ext>
+            </a:extLst>
+          </p:cNvPr>
+          <p:cNvPicPr>
+            <a:picLocks noChangeAspect="1"/>
+          </p:cNvPicPr>
+          <p:nvPr/>
+        </p:nvPicPr>
+        <p:blipFill>
+          <a:blip r:embed="rId2"/>
+          <a:stretch>
+            <a:fillRect/>
+          </a:stretch>
+        </p:blipFill>
+        <p:spPr>
+          <a:xfrm>
+            <a:off x="879771" y="1877960"/>
+            <a:ext cx="3960446" cy="3572828"/>
+          </a:xfrm>
+          <a:prstGeom prst="rect">
+            <a:avLst/>
+          </a:prstGeom>
+        </p:spPr>
+      </p:pic>
+      <p:sp>
+        <p:nvSpPr>
+          <p:cNvPr id="11" name="TextBox 10">
+            <a:extLst>
+              <a:ext uri="{FF2B5EF4-FFF2-40B4-BE49-F238E27FC236}">
+                <a16:creationId xmlns:a16="http://schemas.microsoft.com/office/drawing/2014/main" id="{7BD20E6A-3D9F-1BD3-D239-9F64D8C5F55D}"/>
+              </a:ext>
+            </a:extLst>
+          </p:cNvPr>
+          <p:cNvSpPr txBox="1"/>
+          <p:nvPr/>
+        </p:nvSpPr>
+        <p:spPr>
+          <a:xfrm>
+            <a:off x="4872642" y="4270441"/>
+            <a:ext cx="2373550" cy="1067985"/>
+          </a:xfrm>
+          <a:prstGeom prst="rect">
+            <a:avLst/>
+          </a:prstGeom>
+          <a:noFill/>
+        </p:spPr>
+        <p:txBody>
+          <a:bodyPr wrap="square" lIns="0" tIns="0" rIns="0" bIns="0" rtlCol="0">
+            <a:spAutoFit/>
+          </a:bodyPr>
+          <a:lstStyle/>
+          <a:p>
+            <a:pPr marL="0" indent="0" algn="l" defTabSz="914400" rtl="0" eaLnBrk="1" latinLnBrk="0" hangingPunct="1">
+              <a:lnSpc>
+                <a:spcPct val="90000"/>
+              </a:lnSpc>
+              <a:spcBef>
+                <a:spcPts val="0"/>
+              </a:spcBef>
+              <a:spcAft>
+                <a:spcPts val="600"/>
+              </a:spcAft>
+              <a:buFont typeface="Arial" panose="020B0604020202020204" pitchFamily="34" charset="0"/>
+              <a:buNone/>
+            </a:pPr>
+            <a:r>
+              <a:rPr lang="en-US" sz="1100" b="1" dirty="0">
+                <a:solidFill>
+                  <a:schemeClr val="tx2"/>
+                </a:solidFill>
+                <a:latin typeface="+mn-lt"/>
+                <a:ea typeface="+mn-ea"/>
+              </a:rPr>
+              <a:t>Example test target board:</a:t>
+            </a:r>
+          </a:p>
+          <a:p>
+            <a:pPr marL="168275" indent="-168275" algn="l" defTabSz="914400" rtl="0" eaLnBrk="1" latinLnBrk="0" hangingPunct="1">
+              <a:lnSpc>
+                <a:spcPct val="90000"/>
+              </a:lnSpc>
+              <a:spcBef>
+                <a:spcPts val="0"/>
+              </a:spcBef>
+              <a:spcAft>
+                <a:spcPts val="600"/>
+              </a:spcAft>
+              <a:buFont typeface="Arial" panose="020B0604020202020204" pitchFamily="34" charset="0"/>
+              <a:buChar char="•"/>
+              <a:tabLst>
+                <a:tab pos="344488" algn="l"/>
+              </a:tabLst>
+            </a:pPr>
+            <a:r>
+              <a:rPr lang="en-US" sz="1100" dirty="0">
+                <a:solidFill>
+                  <a:schemeClr val="tx2"/>
+                </a:solidFill>
+                <a:latin typeface="+mn-lt"/>
+                <a:ea typeface="+mn-ea"/>
+              </a:rPr>
+              <a:t>Connects via CMSIS-DAP debug adapter or ST-Link to Raspberry Pi 5 for flash download and test execution</a:t>
+            </a:r>
+          </a:p>
+          <a:p>
+            <a:pPr marL="168275" indent="-168275" algn="l" defTabSz="914400" rtl="0" eaLnBrk="1" latinLnBrk="0" hangingPunct="1">
+              <a:lnSpc>
+                <a:spcPct val="90000"/>
+              </a:lnSpc>
+              <a:spcBef>
+                <a:spcPts val="0"/>
+              </a:spcBef>
+              <a:spcAft>
+                <a:spcPts val="600"/>
+              </a:spcAft>
+              <a:buFont typeface="Arial" panose="020B0604020202020204" pitchFamily="34" charset="0"/>
+              <a:buChar char="•"/>
+              <a:tabLst>
+                <a:tab pos="344488" algn="l"/>
+              </a:tabLst>
+            </a:pPr>
+            <a:r>
+              <a:rPr lang="en-US" sz="1100" dirty="0">
+                <a:solidFill>
+                  <a:schemeClr val="tx2"/>
+                </a:solidFill>
+                <a:latin typeface="+mn-lt"/>
+                <a:ea typeface="+mn-ea"/>
+              </a:rPr>
+              <a:t>Additional USB connection may be used for SDSIO-Server (optional)</a:t>
+            </a:r>
+          </a:p>
+        </p:txBody>
+      </p:sp>
+    </p:spTree>
+    <p:extLst>
+      <p:ext uri="{BB962C8B-B14F-4D97-AF65-F5344CB8AC3E}">
+        <p14:creationId xmlns:p14="http://schemas.microsoft.com/office/powerpoint/2010/main" val="315814053"/>
+      </p:ext>
+    </p:extLst>
+  </p:cSld>
+  <p:clrMapOvr>
+    <a:masterClrMapping/>
+  </p:clrMapOvr>
+</p:sld>
+</file>
+
 <file path=ppt/theme/theme1.xml><?xml version="1.0" encoding="utf-8"?>
 <a:theme xmlns:a="http://schemas.openxmlformats.org/drawingml/2006/main" name="Arm_PPT_Public">
   <a:themeElements>
@@ -18105,40 +18566,12 @@
 </file>
 
 <file path=customXml/item1.xml><?xml version="1.0" encoding="utf-8"?>
-<p:properties xmlns:p="http://schemas.microsoft.com/office/2006/metadata/properties" xmlns:xsi="http://www.w3.org/2001/XMLSchema-instance" xmlns:pc="http://schemas.microsoft.com/office/infopath/2007/PartnerControls">
-  <documentManagement>
-    <Current_x0020_Version xmlns="f2ad5090-61a8-4b8c-ab70-68f4ff4d1933">9.0</Current_x0020_Version>
-    <Document_x0020_Author xmlns="f2ad5090-61a8-4b8c-ab70-68f4ff4d1933">
-      <UserInfo>
-        <DisplayName/>
-        <AccountId xsi:nil="true"/>
-        <AccountType/>
-      </UserInfo>
-    </Document_x0020_Author>
-    <_dlc_DocId xmlns="f2ad5090-61a8-4b8c-ab70-68f4ff4d1933">ARM-ECM-0633231</_dlc_DocId>
-    <Document_x0020_Confidentiality xmlns="f2ad5090-61a8-4b8c-ab70-68f4ff4d1933">Confidential-Restricted</Document_x0020_Confidentiality>
-    <_dlc_DocIdUrl xmlns="f2ad5090-61a8-4b8c-ab70-68f4ff4d1933">
-      <Url>http://teamsites.arm.com/sites/cthub/_layouts/DocIdRedir.aspx?ID=ARM-ECM-0633231</Url>
-      <Description>ARM-ECM-0633231</Description>
-    </_dlc_DocIdUrl>
-    <Category xmlns="c0950e01-db07-4e41-9c32-b7a8e9fccc9b">Private Presentation Templates</Category>
-    <ARM_x0020_Legacy_x0020_ID xmlns="f2ad5090-61a8-4b8c-ab70-68f4ff4d1933" xsi:nil="true"/>
-    <TaxCatchAll xmlns="f2ad5090-61a8-4b8c-ab70-68f4ff4d1933">
-      <Value>7</Value>
-      <Value>1</Value>
-    </TaxCatchAll>
-    <j60c3ced31bb40378c6254d49035d966 xmlns="f2ad5090-61a8-4b8c-ab70-68f4ff4d1933">
-      <Terms xmlns="http://schemas.microsoft.com/office/infopath/2007/PartnerControls">
-        <TermInfo xmlns="http://schemas.microsoft.com/office/infopath/2007/PartnerControls">
-          <TermName xmlns="http://schemas.microsoft.com/office/infopath/2007/PartnerControls">2017</TermName>
-          <TermId xmlns="http://schemas.microsoft.com/office/infopath/2007/PartnerControls">58467e81-5d99-44a5-abb5-12a016b65e9e</TermId>
-        </TermInfo>
-      </Terms>
-    </j60c3ced31bb40378c6254d49035d966>
-    <RoutingRuleDescription xmlns="http://schemas.microsoft.com/sharepoint/v3" xsi:nil="true"/>
-    <_Status xmlns="http://schemas.microsoft.com/sharepoint/v3/fields">Not Started</_Status>
-  </documentManagement>
-</p:properties>
+<?mso-contentType ?>
+<FormTemplates xmlns="http://schemas.microsoft.com/sharepoint/v3/contenttype/forms">
+  <Display>DocumentLibraryForm</Display>
+  <Edit>DocumentLibraryForm</Edit>
+  <New>DocumentLibraryForm</New>
+</FormTemplates>
 </file>
 
 <file path=customXml/item2.xml><?xml version="1.0" encoding="utf-8"?>
@@ -18426,25 +18859,43 @@
 </file>
 
 <file path=customXml/item3.xml><?xml version="1.0" encoding="utf-8"?>
-<?mso-contentType ?>
-<FormTemplates xmlns="http://schemas.microsoft.com/sharepoint/v3/contenttype/forms">
-  <Display>DocumentLibraryForm</Display>
-  <Edit>DocumentLibraryForm</Edit>
-  <New>DocumentLibraryForm</New>
-</FormTemplates>
+<p:properties xmlns:p="http://schemas.microsoft.com/office/2006/metadata/properties" xmlns:xsi="http://www.w3.org/2001/XMLSchema-instance" xmlns:pc="http://schemas.microsoft.com/office/infopath/2007/PartnerControls">
+  <documentManagement>
+    <Current_x0020_Version xmlns="f2ad5090-61a8-4b8c-ab70-68f4ff4d1933">9.0</Current_x0020_Version>
+    <Document_x0020_Author xmlns="f2ad5090-61a8-4b8c-ab70-68f4ff4d1933">
+      <UserInfo>
+        <DisplayName/>
+        <AccountId xsi:nil="true"/>
+        <AccountType/>
+      </UserInfo>
+    </Document_x0020_Author>
+    <_dlc_DocId xmlns="f2ad5090-61a8-4b8c-ab70-68f4ff4d1933">ARM-ECM-0633231</_dlc_DocId>
+    <Document_x0020_Confidentiality xmlns="f2ad5090-61a8-4b8c-ab70-68f4ff4d1933">Confidential-Restricted</Document_x0020_Confidentiality>
+    <_dlc_DocIdUrl xmlns="f2ad5090-61a8-4b8c-ab70-68f4ff4d1933">
+      <Url>http://teamsites.arm.com/sites/cthub/_layouts/DocIdRedir.aspx?ID=ARM-ECM-0633231</Url>
+      <Description>ARM-ECM-0633231</Description>
+    </_dlc_DocIdUrl>
+    <Category xmlns="c0950e01-db07-4e41-9c32-b7a8e9fccc9b">Private Presentation Templates</Category>
+    <ARM_x0020_Legacy_x0020_ID xmlns="f2ad5090-61a8-4b8c-ab70-68f4ff4d1933" xsi:nil="true"/>
+    <TaxCatchAll xmlns="f2ad5090-61a8-4b8c-ab70-68f4ff4d1933">
+      <Value>7</Value>
+      <Value>1</Value>
+    </TaxCatchAll>
+    <j60c3ced31bb40378c6254d49035d966 xmlns="f2ad5090-61a8-4b8c-ab70-68f4ff4d1933">
+      <Terms xmlns="http://schemas.microsoft.com/office/infopath/2007/PartnerControls">
+        <TermInfo xmlns="http://schemas.microsoft.com/office/infopath/2007/PartnerControls">
+          <TermName xmlns="http://schemas.microsoft.com/office/infopath/2007/PartnerControls">2017</TermName>
+          <TermId xmlns="http://schemas.microsoft.com/office/infopath/2007/PartnerControls">58467e81-5d99-44a5-abb5-12a016b65e9e</TermId>
+        </TermInfo>
+      </Terms>
+    </j60c3ced31bb40378c6254d49035d966>
+    <RoutingRuleDescription xmlns="http://schemas.microsoft.com/sharepoint/v3" xsi:nil="true"/>
+    <_Status xmlns="http://schemas.microsoft.com/sharepoint/v3/fields">Not Started</_Status>
+  </documentManagement>
+</p:properties>
 </file>
 
 <file path=customXml/item4.xml><?xml version="1.0" encoding="utf-8"?>
-<?mso-contentType ?>
-<customXsn xmlns="http://schemas.microsoft.com/office/2006/metadata/customXsn">
-  <xsnLocation/>
-  <cached>True</cached>
-  <openByDefault>True</openByDefault>
-  <xsnScope/>
-</customXsn>
-</file>
-
-<file path=customXml/item5.xml><?xml version="1.0" encoding="utf-8"?>
 <?mso-contentType ?>
 <spe:Receivers xmlns:spe="http://schemas.microsoft.com/sharepoint/events">
   <Receiver>
@@ -18490,21 +18941,20 @@
 </spe:Receivers>
 </file>
 
+<file path=customXml/item5.xml><?xml version="1.0" encoding="utf-8"?>
+<?mso-contentType ?>
+<customXsn xmlns="http://schemas.microsoft.com/office/2006/metadata/customXsn">
+  <xsnLocation/>
+  <cached>True</cached>
+  <openByDefault>True</openByDefault>
+  <xsnScope/>
+</customXsn>
+</file>
+
 <file path=customXml/itemProps1.xml><?xml version="1.0" encoding="utf-8"?>
-<ds:datastoreItem xmlns:ds="http://schemas.openxmlformats.org/officeDocument/2006/customXml" ds:itemID="{B61D4E06-5D3F-4994-A4A7-4BA626FA722D}">
+<ds:datastoreItem xmlns:ds="http://schemas.openxmlformats.org/officeDocument/2006/customXml" ds:itemID="{82EFBBFE-5AFC-4CAD-AD38-1CB870BDB255}">
   <ds:schemaRefs>
-    <ds:schemaRef ds:uri="c0950e01-db07-4e41-9c32-b7a8e9fccc9b"/>
-    <ds:schemaRef ds:uri="http://purl.org/dc/elements/1.1/"/>
-    <ds:schemaRef ds:uri="http://schemas.microsoft.com/office/2006/metadata/properties"/>
-    <ds:schemaRef ds:uri="http://schemas.microsoft.com/office/2006/documentManagement/types"/>
-    <ds:schemaRef ds:uri="f2ad5090-61a8-4b8c-ab70-68f4ff4d1933"/>
-    <ds:schemaRef ds:uri="http://schemas.microsoft.com/sharepoint/v3"/>
-    <ds:schemaRef ds:uri="http://purl.org/dc/terms/"/>
-    <ds:schemaRef ds:uri="http://schemas.openxmlformats.org/package/2006/metadata/core-properties"/>
-    <ds:schemaRef ds:uri="http://purl.org/dc/dcmitype/"/>
-    <ds:schemaRef ds:uri="http://schemas.microsoft.com/office/infopath/2007/PartnerControls"/>
-    <ds:schemaRef ds:uri="http://schemas.microsoft.com/sharepoint/v3/fields"/>
-    <ds:schemaRef ds:uri="http://www.w3.org/XML/1998/namespace"/>
+    <ds:schemaRef ds:uri="http://schemas.microsoft.com/sharepoint/v3/contenttype/forms"/>
   </ds:schemaRefs>
 </ds:datastoreItem>
 </file>
@@ -18531,25 +18981,36 @@
 </file>
 
 <file path=customXml/itemProps3.xml><?xml version="1.0" encoding="utf-8"?>
-<ds:datastoreItem xmlns:ds="http://schemas.openxmlformats.org/officeDocument/2006/customXml" ds:itemID="{82EFBBFE-5AFC-4CAD-AD38-1CB870BDB255}">
+<ds:datastoreItem xmlns:ds="http://schemas.openxmlformats.org/officeDocument/2006/customXml" ds:itemID="{B61D4E06-5D3F-4994-A4A7-4BA626FA722D}">
   <ds:schemaRefs>
-    <ds:schemaRef ds:uri="http://schemas.microsoft.com/sharepoint/v3/contenttype/forms"/>
+    <ds:schemaRef ds:uri="c0950e01-db07-4e41-9c32-b7a8e9fccc9b"/>
+    <ds:schemaRef ds:uri="http://purl.org/dc/elements/1.1/"/>
+    <ds:schemaRef ds:uri="http://schemas.microsoft.com/office/2006/metadata/properties"/>
+    <ds:schemaRef ds:uri="http://schemas.microsoft.com/office/2006/documentManagement/types"/>
+    <ds:schemaRef ds:uri="f2ad5090-61a8-4b8c-ab70-68f4ff4d1933"/>
+    <ds:schemaRef ds:uri="http://schemas.microsoft.com/sharepoint/v3"/>
+    <ds:schemaRef ds:uri="http://purl.org/dc/terms/"/>
+    <ds:schemaRef ds:uri="http://schemas.openxmlformats.org/package/2006/metadata/core-properties"/>
+    <ds:schemaRef ds:uri="http://purl.org/dc/dcmitype/"/>
+    <ds:schemaRef ds:uri="http://schemas.microsoft.com/office/infopath/2007/PartnerControls"/>
+    <ds:schemaRef ds:uri="http://schemas.microsoft.com/sharepoint/v3/fields"/>
+    <ds:schemaRef ds:uri="http://www.w3.org/XML/1998/namespace"/>
   </ds:schemaRefs>
 </ds:datastoreItem>
 </file>
 
 <file path=customXml/itemProps4.xml><?xml version="1.0" encoding="utf-8"?>
+<ds:datastoreItem xmlns:ds="http://schemas.openxmlformats.org/officeDocument/2006/customXml" ds:itemID="{1E7F2E56-8924-419D-99E9-79DB71144EB2}">
+  <ds:schemaRefs>
+    <ds:schemaRef ds:uri="http://schemas.microsoft.com/sharepoint/events"/>
+  </ds:schemaRefs>
+</ds:datastoreItem>
+</file>
+
+<file path=customXml/itemProps5.xml><?xml version="1.0" encoding="utf-8"?>
 <ds:datastoreItem xmlns:ds="http://schemas.openxmlformats.org/officeDocument/2006/customXml" ds:itemID="{C959113B-7FA4-40AB-AF85-5C5588D4771C}">
   <ds:schemaRefs>
     <ds:schemaRef ds:uri="http://schemas.microsoft.com/office/2006/metadata/customXsn"/>
   </ds:schemaRefs>
 </ds:datastoreItem>
-</file>
-
-<file path=customXml/itemProps5.xml><?xml version="1.0" encoding="utf-8"?>
-<ds:datastoreItem xmlns:ds="http://schemas.openxmlformats.org/officeDocument/2006/customXml" ds:itemID="{1E7F2E56-8924-419D-99E9-79DB71144EB2}">
-  <ds:schemaRefs>
-    <ds:schemaRef ds:uri="http://schemas.microsoft.com/sharepoint/events"/>
-  </ds:schemaRefs>
-</ds:datastoreItem>
 </file>
</xml_diff>